<commit_message>
Body Paragraphs deck: house analogy before the writing activity
Brian's lesson plan explains the house analogy before students start
writing, but the deck had it as the last slide, after "What it looks
like". It now comes right before the writing slide.

Co-Authored-By: Claude Opus 5.5 <noreply@anthropic.com>
Claude-Session: https://claude.ai/code/session_01UdRZiPuGfgyCyhqFn7imqw
</commit_message>
<xml_diff>
--- a/services/web-app/resources/thesis-essay-decks/lesson-5-body-paragraphs.pptx
+++ b/services/web-app/resources/thesis-essay-decks/lesson-5-body-paragraphs.pptx
@@ -1934,7 +1934,7 @@
           <a:p>
             <a:r>
               <a:rPr lang="en-US" dirty="0"/>
-              <a:t>Today’s YAWP! editor on the Body Paragraphs step. Students start with the first element of their thesis only. Work the room, read paragraphs, encourage; you’ll see confidence rise as the essays take shape. Celebrate it.</a:t>
+              <a:t>Brian’s telling: imagine you’re a real estate agent and the goal is to sell the house. As the buyer drives in they notice the street, the sidewalks, the other houses; that’s the introduction creating context. They walk up the path and into the foyer: the thesis, where they can see the whole argument. You’d never stop there, so you walk them room by room (the body paragraphs), pointing out specific things that make the house worth buying. At the end you walk them back to the front door and point out the neighborhood again, maybe a neighboring house you won’t go into: new ideas you acknowledge without exploring. You place the house in the wider world and make a graceful exit. That’s the conclusion.</a:t>
             </a:r>
             <a:endParaRPr lang="en-US" dirty="0"/>
           </a:p>
@@ -2022,7 +2022,7 @@
           <a:p>
             <a:r>
               <a:rPr lang="en-US" dirty="0"/>
-              <a:t>Brian’s telling: imagine you’re a real estate agent and the goal is to sell the house. As the buyer drives in they notice the street, the sidewalks, the other houses; that’s the introduction creating context. They walk up the path and into the foyer: the thesis, where they can see the whole argument. You’d never stop there, so you walk them room by room (the body paragraphs), pointing out specific things that make the house worth buying. At the end you walk them back to the front door and point out the neighborhood again, maybe a neighboring house you won’t go into: new ideas you acknowledge without exploring. You place the house in the wider world and make a graceful exit. That’s the conclusion.</a:t>
+              <a:t>Today’s YAWP! editor on the Body Paragraphs step. Students start with the first element of their thesis only. Work the room, read paragraphs, encourage; you’ll see confidence rise as the essays take shape. Celebrate it.</a:t>
             </a:r>
             <a:endParaRPr lang="en-US" dirty="0"/>
           </a:p>
@@ -12034,13 +12034,13 @@
             <a:r>
               <a:rPr lang="en-US" sz="1200" b="1" spc="200" kern="0" dirty="0">
                 <a:solidFill>
-                  <a:srgbClr val="FFB600"/>
+                  <a:srgbClr val="FF9755"/>
                 </a:solidFill>
                 <a:latin typeface="Consolas" pitchFamily="34" charset="0"/>
                 <a:ea typeface="Consolas" pitchFamily="34" charset="-122"/>
                 <a:cs typeface="Consolas" pitchFamily="34" charset="-120"/>
               </a:rPr>
-              <a:t>YOUR TURN</a:t>
+              <a:t>THE HOUSE ANALOGY</a:t>
             </a:r>
             <a:endParaRPr lang="en-US" sz="1200" dirty="0"/>
           </a:p>
@@ -12071,7 +12071,7 @@
               <a:buNone/>
             </a:pPr>
             <a:r>
-              <a:rPr lang="en-US" sz="3600" dirty="0">
+              <a:rPr lang="en-US" sz="3000" dirty="0">
                 <a:solidFill>
                   <a:srgbClr val="3C3828"/>
                 </a:solidFill>
@@ -12079,9 +12079,9 @@
                 <a:ea typeface="Georgia" pitchFamily="34" charset="-122"/>
                 <a:cs typeface="Georgia" pitchFamily="34" charset="-120"/>
               </a:rPr>
-              <a:t>What it looks like</a:t>
-            </a:r>
-            <a:endParaRPr lang="en-US" sz="3600" dirty="0"/>
+              <a:t>Your essay is a house, and you’re showing it</a:t>
+            </a:r>
+            <a:endParaRPr lang="en-US" sz="3000" dirty="0"/>
           </a:p>
         </p:txBody>
       </p:sp>
@@ -12093,12 +12093,111 @@
         </p:nvSpPr>
         <p:spPr>
           <a:xfrm>
-            <a:off x="685800" y="1828800"/>
-            <a:ext cx="6949440" cy="4150360"/>
+            <a:off x="10637215" y="457200"/>
+            <a:ext cx="868680" cy="868680"/>
+          </a:xfrm>
+          <a:prstGeom prst="ellipse">
+            <a:avLst/>
+          </a:prstGeom>
+          <a:solidFill>
+            <a:srgbClr val="FF9755"/>
+          </a:solidFill>
+          <a:ln w="12700">
+            <a:solidFill>
+              <a:srgbClr val="FF9755"/>
+            </a:solidFill>
+            <a:prstDash val="solid"/>
+          </a:ln>
+        </p:spPr>
+      </p:sp>
+      <p:pic>
+        <p:nvPicPr>
+          <p:cNvPr id="5" name="Image 0" descr="pencil icon">    </p:cNvPr>
+          <p:cNvPicPr>
+            <a:picLocks noChangeAspect="1"/>
+          </p:cNvPicPr>
+          <p:nvPr/>
+        </p:nvPicPr>
+        <p:blipFill>
+          <a:blip r:embed="rId1"/>
+          <a:stretch>
+            <a:fillRect/>
+          </a:stretch>
+        </p:blipFill>
+        <p:spPr>
+          <a:xfrm>
+            <a:off x="10810951" y="630936"/>
+            <a:ext cx="521208" cy="521208"/>
+          </a:xfrm>
+          <a:prstGeom prst="rect">
+            <a:avLst/>
+          </a:prstGeom>
+        </p:spPr>
+      </p:pic>
+      <p:sp>
+        <p:nvSpPr>
+          <p:cNvPr id="6" name="Shape 3"/>
+          <p:cNvSpPr/>
+          <p:nvPr/>
+        </p:nvSpPr>
+        <p:spPr>
+          <a:xfrm>
+            <a:off x="10344607" y="530352"/>
+            <a:ext cx="182880" cy="182880"/>
+          </a:xfrm>
+          <a:prstGeom prst="ellipse">
+            <a:avLst/>
+          </a:prstGeom>
+          <a:solidFill>
+            <a:srgbClr val="02BDC7"/>
+          </a:solidFill>
+          <a:ln w="12700">
+            <a:solidFill>
+              <a:srgbClr val="02BDC7"/>
+            </a:solidFill>
+            <a:prstDash val="solid"/>
+          </a:ln>
+        </p:spPr>
+      </p:sp>
+      <p:sp>
+        <p:nvSpPr>
+          <p:cNvPr id="7" name="Shape 4"/>
+          <p:cNvSpPr/>
+          <p:nvPr/>
+        </p:nvSpPr>
+        <p:spPr>
+          <a:xfrm>
+            <a:off x="11460175" y="1307592"/>
+            <a:ext cx="128016" cy="128016"/>
+          </a:xfrm>
+          <a:prstGeom prst="ellipse">
+            <a:avLst/>
+          </a:prstGeom>
+          <a:solidFill>
+            <a:srgbClr val="FFB600"/>
+          </a:solidFill>
+          <a:ln w="12700">
+            <a:solidFill>
+              <a:srgbClr val="FFB600"/>
+            </a:solidFill>
+            <a:prstDash val="solid"/>
+          </a:ln>
+        </p:spPr>
+      </p:sp>
+      <p:sp>
+        <p:nvSpPr>
+          <p:cNvPr id="8" name="Shape 5"/>
+          <p:cNvSpPr/>
+          <p:nvPr/>
+        </p:nvSpPr>
+        <p:spPr>
+          <a:xfrm>
+            <a:off x="685800" y="1965960"/>
+            <a:ext cx="5250028" cy="1897380"/>
           </a:xfrm>
           <a:prstGeom prst="roundRect">
             <a:avLst>
-              <a:gd name="adj" fmla="val 3084"/>
+              <a:gd name="adj" fmla="val 6747"/>
             </a:avLst>
           </a:prstGeom>
           <a:solidFill>
@@ -12119,65 +12218,66 @@
           </a:effectLst>
         </p:spPr>
       </p:sp>
-      <p:pic>
-        <p:nvPicPr>
-          <p:cNvPr id="5" name="Image 0" descr="The YAWP! editor on the Body Paragraphs step.">    </p:cNvPr>
-          <p:cNvPicPr>
-            <a:picLocks noChangeAspect="1"/>
-          </p:cNvPicPr>
-          <p:nvPr/>
-        </p:nvPicPr>
-        <p:blipFill>
-          <a:blip r:embed="rId1"/>
-          <a:stretch>
-            <a:fillRect/>
-          </a:stretch>
-        </p:blipFill>
-        <p:spPr>
-          <a:xfrm>
-            <a:off x="813816" y="1956816"/>
-            <a:ext cx="6693408" cy="3894328"/>
-          </a:xfrm>
-          <a:prstGeom prst="rect">
-            <a:avLst/>
-          </a:prstGeom>
-        </p:spPr>
-      </p:pic>
-      <p:sp>
-        <p:nvSpPr>
-          <p:cNvPr id="6" name="Shape 3"/>
-          <p:cNvSpPr/>
-          <p:nvPr/>
-        </p:nvSpPr>
-        <p:spPr>
-          <a:xfrm>
-            <a:off x="8183880" y="2505456"/>
-            <a:ext cx="292608" cy="292608"/>
+      <p:sp>
+        <p:nvSpPr>
+          <p:cNvPr id="9" name="Shape 6"/>
+          <p:cNvSpPr/>
+          <p:nvPr/>
+        </p:nvSpPr>
+        <p:spPr>
+          <a:xfrm>
+            <a:off x="813816" y="1965960"/>
+            <a:ext cx="4993996" cy="91440"/>
+          </a:xfrm>
+          <a:prstGeom prst="rect">
+            <a:avLst/>
+          </a:prstGeom>
+          <a:solidFill>
+            <a:srgbClr val="FF9755"/>
+          </a:solidFill>
+          <a:ln w="12700">
+            <a:solidFill>
+              <a:srgbClr val="FF9755"/>
+            </a:solidFill>
+            <a:prstDash val="solid"/>
+          </a:ln>
+        </p:spPr>
+      </p:sp>
+      <p:sp>
+        <p:nvSpPr>
+          <p:cNvPr id="10" name="Shape 7"/>
+          <p:cNvSpPr/>
+          <p:nvPr/>
+        </p:nvSpPr>
+        <p:spPr>
+          <a:xfrm>
+            <a:off x="960120" y="2286000"/>
+            <a:ext cx="548640" cy="548640"/>
           </a:xfrm>
           <a:prstGeom prst="ellipse">
             <a:avLst/>
           </a:prstGeom>
           <a:solidFill>
-            <a:srgbClr val="FFB600"/>
+            <a:srgbClr val="FF9755"/>
           </a:solidFill>
           <a:ln w="12700">
             <a:solidFill>
-              <a:srgbClr val="FFB600"/>
-            </a:solidFill>
-            <a:prstDash val="solid"/>
-          </a:ln>
-        </p:spPr>
-      </p:sp>
-      <p:sp>
-        <p:nvSpPr>
-          <p:cNvPr id="7" name="Text 4"/>
-          <p:cNvSpPr/>
-          <p:nvPr/>
-        </p:nvSpPr>
-        <p:spPr>
-          <a:xfrm>
-            <a:off x="8659368" y="2194560"/>
-            <a:ext cx="2846527" cy="914400"/>
+              <a:srgbClr val="FF9755"/>
+            </a:solidFill>
+            <a:prstDash val="solid"/>
+          </a:ln>
+        </p:spPr>
+      </p:sp>
+      <p:sp>
+        <p:nvSpPr>
+          <p:cNvPr id="11" name="Text 8"/>
+          <p:cNvSpPr/>
+          <p:nvPr/>
+        </p:nvSpPr>
+        <p:spPr>
+          <a:xfrm>
+            <a:off x="960120" y="2286000"/>
+            <a:ext cx="548640" cy="548640"/>
           </a:xfrm>
           <a:prstGeom prst="rect">
             <a:avLst/>
@@ -12189,20 +12289,48 @@
           <a:bodyPr wrap="square" lIns="0" tIns="0" rIns="0" bIns="0" rtlCol="0" anchor="ctr"/>
           <a:lstStyle/>
           <a:p>
+            <a:pPr algn="ctr" indent="0" marL="0">
+              <a:buNone/>
+            </a:pPr>
+            <a:r>
+              <a:rPr lang="en-US" sz="2200" b="1" dirty="0">
+                <a:solidFill>
+                  <a:srgbClr val="FFFEFA"/>
+                </a:solidFill>
+                <a:latin typeface="Georgia" pitchFamily="34" charset="0"/>
+                <a:ea typeface="Georgia" pitchFamily="34" charset="-122"/>
+                <a:cs typeface="Georgia" pitchFamily="34" charset="-120"/>
+              </a:rPr>
+              <a:t>1</a:t>
+            </a:r>
+            <a:endParaRPr lang="en-US" sz="2200" dirty="0"/>
+          </a:p>
+        </p:txBody>
+      </p:sp>
+      <p:sp>
+        <p:nvSpPr>
+          <p:cNvPr id="12" name="Text 9"/>
+          <p:cNvSpPr/>
+          <p:nvPr/>
+        </p:nvSpPr>
+        <p:spPr>
+          <a:xfrm>
+            <a:off x="1737360" y="2194560"/>
+            <a:ext cx="3924148" cy="1485900"/>
+          </a:xfrm>
+          <a:prstGeom prst="rect">
+            <a:avLst/>
+          </a:prstGeom>
+          <a:noFill/>
+          <a:ln/>
+        </p:spPr>
+        <p:txBody>
+          <a:bodyPr wrap="square" lIns="0" tIns="0" rIns="0" bIns="0" rtlCol="0" anchor="t"/>
+          <a:lstStyle/>
+          <a:p>
             <a:pPr indent="0" marL="0">
               <a:buNone/>
             </a:pPr>
-            <a:r>
-              <a:rPr lang="en-US" sz="2000" dirty="0">
-                <a:solidFill>
-                  <a:srgbClr val="3C3828"/>
-                </a:solidFill>
-                <a:latin typeface="Calibri" pitchFamily="34" charset="0"/>
-                <a:ea typeface="Calibri" pitchFamily="34" charset="-122"/>
-                <a:cs typeface="Calibri" pitchFamily="34" charset="-120"/>
-              </a:rPr>
-              <a:t>The Tutor says </a:t>
-            </a:r>
             <a:r>
               <a:rPr lang="en-US" sz="2000" dirty="0">
                 <a:solidFill>
@@ -12215,61 +12343,8 @@
                 <a:ea typeface="Calibri" pitchFamily="34" charset="-122"/>
                 <a:cs typeface="Calibri" pitchFamily="34" charset="-120"/>
               </a:rPr>
-              <a:t>Body Paragraphs</a:t>
-            </a:r>
-            <a:endParaRPr lang="en-US" sz="2000" dirty="0"/>
-          </a:p>
-        </p:txBody>
-      </p:sp>
-      <p:sp>
-        <p:nvSpPr>
-          <p:cNvPr id="8" name="Shape 5"/>
-          <p:cNvSpPr/>
-          <p:nvPr/>
-        </p:nvSpPr>
-        <p:spPr>
-          <a:xfrm>
-            <a:off x="8183880" y="3419856"/>
-            <a:ext cx="292608" cy="292608"/>
-          </a:xfrm>
-          <a:prstGeom prst="ellipse">
-            <a:avLst/>
-          </a:prstGeom>
-          <a:solidFill>
-            <a:srgbClr val="FC4540"/>
-          </a:solidFill>
-          <a:ln w="12700">
-            <a:solidFill>
-              <a:srgbClr val="FC4540"/>
-            </a:solidFill>
-            <a:prstDash val="solid"/>
-          </a:ln>
-        </p:spPr>
-      </p:sp>
-      <p:sp>
-        <p:nvSpPr>
-          <p:cNvPr id="9" name="Text 6"/>
-          <p:cNvSpPr/>
-          <p:nvPr/>
-        </p:nvSpPr>
-        <p:spPr>
-          <a:xfrm>
-            <a:off x="8659368" y="3108960"/>
-            <a:ext cx="2846527" cy="914400"/>
-          </a:xfrm>
-          <a:prstGeom prst="rect">
-            <a:avLst/>
-          </a:prstGeom>
-          <a:noFill/>
-          <a:ln/>
-        </p:spPr>
-        <p:txBody>
-          <a:bodyPr wrap="square" lIns="0" tIns="0" rIns="0" bIns="0" rtlCol="0" anchor="ctr"/>
-          <a:lstStyle/>
-          <a:p>
-            <a:pPr indent="0" marL="0">
-              <a:buNone/>
-            </a:pPr>
+              <a:t>The neighborhood</a:t>
+            </a:r>
             <a:r>
               <a:rPr lang="en-US" sz="2000" dirty="0">
                 <a:solidFill>
@@ -12279,7 +12354,7 @@
                 <a:ea typeface="Calibri" pitchFamily="34" charset="-122"/>
                 <a:cs typeface="Calibri" pitchFamily="34" charset="-120"/>
               </a:rPr>
-              <a:t>Your thesis, in its parts</a:t>
+              <a:t> · Driving in, your reader gets a sense of where they are. That’s your introduction: context.</a:t>
             </a:r>
             <a:endParaRPr lang="en-US" sz="2000" dirty="0"/>
           </a:p>
@@ -12287,39 +12362,98 @@
       </p:sp>
       <p:sp>
         <p:nvSpPr>
-          <p:cNvPr id="10" name="Shape 7"/>
-          <p:cNvSpPr/>
-          <p:nvPr/>
-        </p:nvSpPr>
-        <p:spPr>
-          <a:xfrm>
-            <a:off x="8183880" y="4334256"/>
-            <a:ext cx="292608" cy="292608"/>
+          <p:cNvPr id="13" name="Shape 10"/>
+          <p:cNvSpPr/>
+          <p:nvPr/>
+        </p:nvSpPr>
+        <p:spPr>
+          <a:xfrm>
+            <a:off x="6255868" y="1965960"/>
+            <a:ext cx="5250028" cy="1897380"/>
+          </a:xfrm>
+          <a:prstGeom prst="roundRect">
+            <a:avLst>
+              <a:gd name="adj" fmla="val 6747"/>
+            </a:avLst>
+          </a:prstGeom>
+          <a:solidFill>
+            <a:srgbClr val="FFFEFA"/>
+          </a:solidFill>
+          <a:ln w="9525">
+            <a:solidFill>
+              <a:srgbClr val="D6D4CC"/>
+            </a:solidFill>
+            <a:prstDash val="solid"/>
+          </a:ln>
+          <a:effectLst>
+            <a:outerShdw sx="100000" sy="100000" kx="0" ky="0" algn="bl" rotWithShape="0" blurRad="127000" dist="38100" dir="5400000">
+              <a:srgbClr val="3C3828">
+                <a:alpha val="12000"/>
+              </a:srgbClr>
+            </a:outerShdw>
+          </a:effectLst>
+        </p:spPr>
+      </p:sp>
+      <p:sp>
+        <p:nvSpPr>
+          <p:cNvPr id="14" name="Shape 11"/>
+          <p:cNvSpPr/>
+          <p:nvPr/>
+        </p:nvSpPr>
+        <p:spPr>
+          <a:xfrm>
+            <a:off x="6383884" y="1965960"/>
+            <a:ext cx="4993996" cy="91440"/>
+          </a:xfrm>
+          <a:prstGeom prst="rect">
+            <a:avLst/>
+          </a:prstGeom>
+          <a:solidFill>
+            <a:srgbClr val="FC4067"/>
+          </a:solidFill>
+          <a:ln w="12700">
+            <a:solidFill>
+              <a:srgbClr val="FC4067"/>
+            </a:solidFill>
+            <a:prstDash val="solid"/>
+          </a:ln>
+        </p:spPr>
+      </p:sp>
+      <p:sp>
+        <p:nvSpPr>
+          <p:cNvPr id="15" name="Shape 12"/>
+          <p:cNvSpPr/>
+          <p:nvPr/>
+        </p:nvSpPr>
+        <p:spPr>
+          <a:xfrm>
+            <a:off x="6530188" y="2286000"/>
+            <a:ext cx="548640" cy="548640"/>
           </a:xfrm>
           <a:prstGeom prst="ellipse">
             <a:avLst/>
           </a:prstGeom>
           <a:solidFill>
-            <a:srgbClr val="FF9755"/>
+            <a:srgbClr val="FC4067"/>
           </a:solidFill>
           <a:ln w="12700">
             <a:solidFill>
-              <a:srgbClr val="FF9755"/>
-            </a:solidFill>
-            <a:prstDash val="solid"/>
-          </a:ln>
-        </p:spPr>
-      </p:sp>
-      <p:sp>
-        <p:nvSpPr>
-          <p:cNvPr id="11" name="Text 8"/>
-          <p:cNvSpPr/>
-          <p:nvPr/>
-        </p:nvSpPr>
-        <p:spPr>
-          <a:xfrm>
-            <a:off x="8659368" y="4023360"/>
-            <a:ext cx="2846527" cy="914400"/>
+              <a:srgbClr val="FC4067"/>
+            </a:solidFill>
+            <a:prstDash val="solid"/>
+          </a:ln>
+        </p:spPr>
+      </p:sp>
+      <p:sp>
+        <p:nvSpPr>
+          <p:cNvPr id="16" name="Text 13"/>
+          <p:cNvSpPr/>
+          <p:nvPr/>
+        </p:nvSpPr>
+        <p:spPr>
+          <a:xfrm>
+            <a:off x="6530188" y="2286000"/>
+            <a:ext cx="548640" cy="548640"/>
           </a:xfrm>
           <a:prstGeom prst="rect">
             <a:avLst/>
@@ -12331,6 +12465,45 @@
           <a:bodyPr wrap="square" lIns="0" tIns="0" rIns="0" bIns="0" rtlCol="0" anchor="ctr"/>
           <a:lstStyle/>
           <a:p>
+            <a:pPr algn="ctr" indent="0" marL="0">
+              <a:buNone/>
+            </a:pPr>
+            <a:r>
+              <a:rPr lang="en-US" sz="2200" b="1" dirty="0">
+                <a:solidFill>
+                  <a:srgbClr val="FFFEFA"/>
+                </a:solidFill>
+                <a:latin typeface="Georgia" pitchFamily="34" charset="0"/>
+                <a:ea typeface="Georgia" pitchFamily="34" charset="-122"/>
+                <a:cs typeface="Georgia" pitchFamily="34" charset="-120"/>
+              </a:rPr>
+              <a:t>2</a:t>
+            </a:r>
+            <a:endParaRPr lang="en-US" sz="2200" dirty="0"/>
+          </a:p>
+        </p:txBody>
+      </p:sp>
+      <p:sp>
+        <p:nvSpPr>
+          <p:cNvPr id="17" name="Text 14"/>
+          <p:cNvSpPr/>
+          <p:nvPr/>
+        </p:nvSpPr>
+        <p:spPr>
+          <a:xfrm>
+            <a:off x="7307428" y="2194560"/>
+            <a:ext cx="3924148" cy="1485900"/>
+          </a:xfrm>
+          <a:prstGeom prst="rect">
+            <a:avLst/>
+          </a:prstGeom>
+          <a:noFill/>
+          <a:ln/>
+        </p:spPr>
+        <p:txBody>
+          <a:bodyPr wrap="square" lIns="0" tIns="0" rIns="0" bIns="0" rtlCol="0" anchor="t"/>
+          <a:lstStyle/>
+          <a:p>
             <a:pPr indent="0" marL="0">
               <a:buNone/>
             </a:pPr>
@@ -12339,65 +12512,15 @@
                 <a:solidFill>
                   <a:srgbClr val="3C3828"/>
                 </a:solidFill>
+                <a:highlight>
+                  <a:srgbClr val="FFE14D"/>
+                </a:highlight>
                 <a:latin typeface="Calibri" pitchFamily="34" charset="0"/>
                 <a:ea typeface="Calibri" pitchFamily="34" charset="-122"/>
                 <a:cs typeface="Calibri" pitchFamily="34" charset="-120"/>
               </a:rPr>
-              <a:t>One paragraph per part</a:t>
-            </a:r>
-            <a:endParaRPr lang="en-US" sz="2000" dirty="0"/>
-          </a:p>
-        </p:txBody>
-      </p:sp>
-      <p:sp>
-        <p:nvSpPr>
-          <p:cNvPr id="12" name="Shape 9"/>
-          <p:cNvSpPr/>
-          <p:nvPr/>
-        </p:nvSpPr>
-        <p:spPr>
-          <a:xfrm>
-            <a:off x="8183880" y="5248656"/>
-            <a:ext cx="292608" cy="292608"/>
-          </a:xfrm>
-          <a:prstGeom prst="ellipse">
-            <a:avLst/>
-          </a:prstGeom>
-          <a:solidFill>
-            <a:srgbClr val="FC4067"/>
-          </a:solidFill>
-          <a:ln w="12700">
-            <a:solidFill>
-              <a:srgbClr val="FC4067"/>
-            </a:solidFill>
-            <a:prstDash val="solid"/>
-          </a:ln>
-        </p:spPr>
-      </p:sp>
-      <p:sp>
-        <p:nvSpPr>
-          <p:cNvPr id="13" name="Text 10"/>
-          <p:cNvSpPr/>
-          <p:nvPr/>
-        </p:nvSpPr>
-        <p:spPr>
-          <a:xfrm>
-            <a:off x="8659368" y="4937760"/>
-            <a:ext cx="2846527" cy="914400"/>
-          </a:xfrm>
-          <a:prstGeom prst="rect">
-            <a:avLst/>
-          </a:prstGeom>
-          <a:noFill/>
-          <a:ln/>
-        </p:spPr>
-        <p:txBody>
-          <a:bodyPr wrap="square" lIns="0" tIns="0" rIns="0" bIns="0" rtlCol="0" anchor="ctr"/>
-          <a:lstStyle/>
-          <a:p>
-            <a:pPr indent="0" marL="0">
-              <a:buNone/>
-            </a:pPr>
+              <a:t>The front door</a:t>
+            </a:r>
             <a:r>
               <a:rPr lang="en-US" sz="2000" dirty="0">
                 <a:solidFill>
@@ -12407,7 +12530,359 @@
                 <a:ea typeface="Calibri" pitchFamily="34" charset="-122"/>
                 <a:cs typeface="Calibri" pitchFamily="34" charset="-120"/>
               </a:rPr>
-              <a:t>Written one? Ask the Tutor for feedback</a:t>
+              <a:t> · They step into the foyer and see the whole house at once. That’s your thesis statement.</a:t>
+            </a:r>
+            <a:endParaRPr lang="en-US" sz="2000" dirty="0"/>
+          </a:p>
+        </p:txBody>
+      </p:sp>
+      <p:sp>
+        <p:nvSpPr>
+          <p:cNvPr id="18" name="Shape 15"/>
+          <p:cNvSpPr/>
+          <p:nvPr/>
+        </p:nvSpPr>
+        <p:spPr>
+          <a:xfrm>
+            <a:off x="685800" y="4183380"/>
+            <a:ext cx="5250028" cy="1897380"/>
+          </a:xfrm>
+          <a:prstGeom prst="roundRect">
+            <a:avLst>
+              <a:gd name="adj" fmla="val 6747"/>
+            </a:avLst>
+          </a:prstGeom>
+          <a:solidFill>
+            <a:srgbClr val="FFFEFA"/>
+          </a:solidFill>
+          <a:ln w="9525">
+            <a:solidFill>
+              <a:srgbClr val="D6D4CC"/>
+            </a:solidFill>
+            <a:prstDash val="solid"/>
+          </a:ln>
+          <a:effectLst>
+            <a:outerShdw sx="100000" sy="100000" kx="0" ky="0" algn="bl" rotWithShape="0" blurRad="127000" dist="38100" dir="5400000">
+              <a:srgbClr val="3C3828">
+                <a:alpha val="12000"/>
+              </a:srgbClr>
+            </a:outerShdw>
+          </a:effectLst>
+        </p:spPr>
+      </p:sp>
+      <p:sp>
+        <p:nvSpPr>
+          <p:cNvPr id="19" name="Shape 16"/>
+          <p:cNvSpPr/>
+          <p:nvPr/>
+        </p:nvSpPr>
+        <p:spPr>
+          <a:xfrm>
+            <a:off x="813816" y="4183380"/>
+            <a:ext cx="4993996" cy="91440"/>
+          </a:xfrm>
+          <a:prstGeom prst="rect">
+            <a:avLst/>
+          </a:prstGeom>
+          <a:solidFill>
+            <a:srgbClr val="02BDC7"/>
+          </a:solidFill>
+          <a:ln w="12700">
+            <a:solidFill>
+              <a:srgbClr val="02BDC7"/>
+            </a:solidFill>
+            <a:prstDash val="solid"/>
+          </a:ln>
+        </p:spPr>
+      </p:sp>
+      <p:sp>
+        <p:nvSpPr>
+          <p:cNvPr id="20" name="Shape 17"/>
+          <p:cNvSpPr/>
+          <p:nvPr/>
+        </p:nvSpPr>
+        <p:spPr>
+          <a:xfrm>
+            <a:off x="960120" y="4503420"/>
+            <a:ext cx="548640" cy="548640"/>
+          </a:xfrm>
+          <a:prstGeom prst="ellipse">
+            <a:avLst/>
+          </a:prstGeom>
+          <a:solidFill>
+            <a:srgbClr val="02BDC7"/>
+          </a:solidFill>
+          <a:ln w="12700">
+            <a:solidFill>
+              <a:srgbClr val="02BDC7"/>
+            </a:solidFill>
+            <a:prstDash val="solid"/>
+          </a:ln>
+        </p:spPr>
+      </p:sp>
+      <p:sp>
+        <p:nvSpPr>
+          <p:cNvPr id="21" name="Text 18"/>
+          <p:cNvSpPr/>
+          <p:nvPr/>
+        </p:nvSpPr>
+        <p:spPr>
+          <a:xfrm>
+            <a:off x="960120" y="4503420"/>
+            <a:ext cx="548640" cy="548640"/>
+          </a:xfrm>
+          <a:prstGeom prst="rect">
+            <a:avLst/>
+          </a:prstGeom>
+          <a:noFill/>
+          <a:ln/>
+        </p:spPr>
+        <p:txBody>
+          <a:bodyPr wrap="square" lIns="0" tIns="0" rIns="0" bIns="0" rtlCol="0" anchor="ctr"/>
+          <a:lstStyle/>
+          <a:p>
+            <a:pPr algn="ctr" indent="0" marL="0">
+              <a:buNone/>
+            </a:pPr>
+            <a:r>
+              <a:rPr lang="en-US" sz="2200" b="1" dirty="0">
+                <a:solidFill>
+                  <a:srgbClr val="FFFEFA"/>
+                </a:solidFill>
+                <a:latin typeface="Georgia" pitchFamily="34" charset="0"/>
+                <a:ea typeface="Georgia" pitchFamily="34" charset="-122"/>
+                <a:cs typeface="Georgia" pitchFamily="34" charset="-120"/>
+              </a:rPr>
+              <a:t>3</a:t>
+            </a:r>
+            <a:endParaRPr lang="en-US" sz="2200" dirty="0"/>
+          </a:p>
+        </p:txBody>
+      </p:sp>
+      <p:sp>
+        <p:nvSpPr>
+          <p:cNvPr id="22" name="Text 19"/>
+          <p:cNvSpPr/>
+          <p:nvPr/>
+        </p:nvSpPr>
+        <p:spPr>
+          <a:xfrm>
+            <a:off x="1737360" y="4411980"/>
+            <a:ext cx="3924148" cy="1485900"/>
+          </a:xfrm>
+          <a:prstGeom prst="rect">
+            <a:avLst/>
+          </a:prstGeom>
+          <a:noFill/>
+          <a:ln/>
+        </p:spPr>
+        <p:txBody>
+          <a:bodyPr wrap="square" lIns="0" tIns="0" rIns="0" bIns="0" rtlCol="0" anchor="t"/>
+          <a:lstStyle/>
+          <a:p>
+            <a:pPr indent="0" marL="0">
+              <a:buNone/>
+            </a:pPr>
+            <a:r>
+              <a:rPr lang="en-US" sz="2000" dirty="0">
+                <a:solidFill>
+                  <a:srgbClr val="3C3828"/>
+                </a:solidFill>
+                <a:highlight>
+                  <a:srgbClr val="FFE14D"/>
+                </a:highlight>
+                <a:latin typeface="Calibri" pitchFamily="34" charset="0"/>
+                <a:ea typeface="Calibri" pitchFamily="34" charset="-122"/>
+                <a:cs typeface="Calibri" pitchFamily="34" charset="-120"/>
+              </a:rPr>
+              <a:t>The rooms</a:t>
+            </a:r>
+            <a:r>
+              <a:rPr lang="en-US" sz="2000" dirty="0">
+                <a:solidFill>
+                  <a:srgbClr val="3C3828"/>
+                </a:solidFill>
+                <a:latin typeface="Calibri" pitchFamily="34" charset="0"/>
+                <a:ea typeface="Calibri" pitchFamily="34" charset="-122"/>
+                <a:cs typeface="Calibri" pitchFamily="34" charset="-120"/>
+              </a:rPr>
+              <a:t> · You walk them through, pointing out what makes each room worth it. Those are your body paragraphs.</a:t>
+            </a:r>
+            <a:endParaRPr lang="en-US" sz="2000" dirty="0"/>
+          </a:p>
+        </p:txBody>
+      </p:sp>
+      <p:sp>
+        <p:nvSpPr>
+          <p:cNvPr id="23" name="Shape 20"/>
+          <p:cNvSpPr/>
+          <p:nvPr/>
+        </p:nvSpPr>
+        <p:spPr>
+          <a:xfrm>
+            <a:off x="6255868" y="4183380"/>
+            <a:ext cx="5250028" cy="1897380"/>
+          </a:xfrm>
+          <a:prstGeom prst="roundRect">
+            <a:avLst>
+              <a:gd name="adj" fmla="val 6747"/>
+            </a:avLst>
+          </a:prstGeom>
+          <a:solidFill>
+            <a:srgbClr val="FFFEFA"/>
+          </a:solidFill>
+          <a:ln w="9525">
+            <a:solidFill>
+              <a:srgbClr val="D6D4CC"/>
+            </a:solidFill>
+            <a:prstDash val="solid"/>
+          </a:ln>
+          <a:effectLst>
+            <a:outerShdw sx="100000" sy="100000" kx="0" ky="0" algn="bl" rotWithShape="0" blurRad="127000" dist="38100" dir="5400000">
+              <a:srgbClr val="3C3828">
+                <a:alpha val="12000"/>
+              </a:srgbClr>
+            </a:outerShdw>
+          </a:effectLst>
+        </p:spPr>
+      </p:sp>
+      <p:sp>
+        <p:nvSpPr>
+          <p:cNvPr id="24" name="Shape 21"/>
+          <p:cNvSpPr/>
+          <p:nvPr/>
+        </p:nvSpPr>
+        <p:spPr>
+          <a:xfrm>
+            <a:off x="6383884" y="4183380"/>
+            <a:ext cx="4993996" cy="91440"/>
+          </a:xfrm>
+          <a:prstGeom prst="rect">
+            <a:avLst/>
+          </a:prstGeom>
+          <a:solidFill>
+            <a:srgbClr val="FFB600"/>
+          </a:solidFill>
+          <a:ln w="12700">
+            <a:solidFill>
+              <a:srgbClr val="FFB600"/>
+            </a:solidFill>
+            <a:prstDash val="solid"/>
+          </a:ln>
+        </p:spPr>
+      </p:sp>
+      <p:sp>
+        <p:nvSpPr>
+          <p:cNvPr id="25" name="Shape 22"/>
+          <p:cNvSpPr/>
+          <p:nvPr/>
+        </p:nvSpPr>
+        <p:spPr>
+          <a:xfrm>
+            <a:off x="6530188" y="4503420"/>
+            <a:ext cx="548640" cy="548640"/>
+          </a:xfrm>
+          <a:prstGeom prst="ellipse">
+            <a:avLst/>
+          </a:prstGeom>
+          <a:solidFill>
+            <a:srgbClr val="FFB600"/>
+          </a:solidFill>
+          <a:ln w="12700">
+            <a:solidFill>
+              <a:srgbClr val="FFB600"/>
+            </a:solidFill>
+            <a:prstDash val="solid"/>
+          </a:ln>
+        </p:spPr>
+      </p:sp>
+      <p:sp>
+        <p:nvSpPr>
+          <p:cNvPr id="26" name="Text 23"/>
+          <p:cNvSpPr/>
+          <p:nvPr/>
+        </p:nvSpPr>
+        <p:spPr>
+          <a:xfrm>
+            <a:off x="6530188" y="4503420"/>
+            <a:ext cx="548640" cy="548640"/>
+          </a:xfrm>
+          <a:prstGeom prst="rect">
+            <a:avLst/>
+          </a:prstGeom>
+          <a:noFill/>
+          <a:ln/>
+        </p:spPr>
+        <p:txBody>
+          <a:bodyPr wrap="square" lIns="0" tIns="0" rIns="0" bIns="0" rtlCol="0" anchor="ctr"/>
+          <a:lstStyle/>
+          <a:p>
+            <a:pPr algn="ctr" indent="0" marL="0">
+              <a:buNone/>
+            </a:pPr>
+            <a:r>
+              <a:rPr lang="en-US" sz="2200" b="1" dirty="0">
+                <a:solidFill>
+                  <a:srgbClr val="FFFEFA"/>
+                </a:solidFill>
+                <a:latin typeface="Georgia" pitchFamily="34" charset="0"/>
+                <a:ea typeface="Georgia" pitchFamily="34" charset="-122"/>
+                <a:cs typeface="Georgia" pitchFamily="34" charset="-120"/>
+              </a:rPr>
+              <a:t>4</a:t>
+            </a:r>
+            <a:endParaRPr lang="en-US" sz="2200" dirty="0"/>
+          </a:p>
+        </p:txBody>
+      </p:sp>
+      <p:sp>
+        <p:nvSpPr>
+          <p:cNvPr id="27" name="Text 24"/>
+          <p:cNvSpPr/>
+          <p:nvPr/>
+        </p:nvSpPr>
+        <p:spPr>
+          <a:xfrm>
+            <a:off x="7307428" y="4411980"/>
+            <a:ext cx="3924148" cy="1485900"/>
+          </a:xfrm>
+          <a:prstGeom prst="rect">
+            <a:avLst/>
+          </a:prstGeom>
+          <a:noFill/>
+          <a:ln/>
+        </p:spPr>
+        <p:txBody>
+          <a:bodyPr wrap="square" lIns="0" tIns="0" rIns="0" bIns="0" rtlCol="0" anchor="t"/>
+          <a:lstStyle/>
+          <a:p>
+            <a:pPr indent="0" marL="0">
+              <a:buNone/>
+            </a:pPr>
+            <a:r>
+              <a:rPr lang="en-US" sz="2000" dirty="0">
+                <a:solidFill>
+                  <a:srgbClr val="3C3828"/>
+                </a:solidFill>
+                <a:highlight>
+                  <a:srgbClr val="FFE14D"/>
+                </a:highlight>
+                <a:latin typeface="Calibri" pitchFamily="34" charset="0"/>
+                <a:ea typeface="Calibri" pitchFamily="34" charset="-122"/>
+                <a:cs typeface="Calibri" pitchFamily="34" charset="-120"/>
+              </a:rPr>
+              <a:t>Back at the door</a:t>
+            </a:r>
+            <a:r>
+              <a:rPr lang="en-US" sz="2000" dirty="0">
+                <a:solidFill>
+                  <a:srgbClr val="3C3828"/>
+                </a:solidFill>
+                <a:latin typeface="Calibri" pitchFamily="34" charset="0"/>
+                <a:ea typeface="Calibri" pitchFamily="34" charset="-122"/>
+                <a:cs typeface="Calibri" pitchFamily="34" charset="-120"/>
+              </a:rPr>
+              <a:t> · You step out, point at the neighborhood, and leave gracefully. That’s your conclusion.</a:t>
             </a:r>
             <a:endParaRPr lang="en-US" sz="2000" dirty="0"/>
           </a:p>
@@ -12513,13 +12988,13 @@
             <a:r>
               <a:rPr lang="en-US" sz="1200" b="1" spc="200" kern="0" dirty="0">
                 <a:solidFill>
-                  <a:srgbClr val="FF9755"/>
+                  <a:srgbClr val="FFB600"/>
                 </a:solidFill>
                 <a:latin typeface="Consolas" pitchFamily="34" charset="0"/>
                 <a:ea typeface="Consolas" pitchFamily="34" charset="-122"/>
                 <a:cs typeface="Consolas" pitchFamily="34" charset="-120"/>
               </a:rPr>
-              <a:t>THE HOUSE ANALOGY</a:t>
+              <a:t>YOUR TURN</a:t>
             </a:r>
             <a:endParaRPr lang="en-US" sz="1200" dirty="0"/>
           </a:p>
@@ -12550,7 +13025,7 @@
               <a:buNone/>
             </a:pPr>
             <a:r>
-              <a:rPr lang="en-US" sz="3000" dirty="0">
+              <a:rPr lang="en-US" sz="3600" dirty="0">
                 <a:solidFill>
                   <a:srgbClr val="3C3828"/>
                 </a:solidFill>
@@ -12558,9 +13033,9 @@
                 <a:ea typeface="Georgia" pitchFamily="34" charset="-122"/>
                 <a:cs typeface="Georgia" pitchFamily="34" charset="-120"/>
               </a:rPr>
-              <a:t>Your essay is a house, and you’re showing it</a:t>
-            </a:r>
-            <a:endParaRPr lang="en-US" sz="3000" dirty="0"/>
+              <a:t>What it looks like</a:t>
+            </a:r>
+            <a:endParaRPr lang="en-US" sz="3600" dirty="0"/>
           </a:p>
         </p:txBody>
       </p:sp>
@@ -12572,26 +13047,35 @@
         </p:nvSpPr>
         <p:spPr>
           <a:xfrm>
-            <a:off x="10637215" y="457200"/>
-            <a:ext cx="868680" cy="868680"/>
-          </a:xfrm>
-          <a:prstGeom prst="ellipse">
-            <a:avLst/>
-          </a:prstGeom>
-          <a:solidFill>
-            <a:srgbClr val="FF9755"/>
-          </a:solidFill>
-          <a:ln w="12700">
-            <a:solidFill>
-              <a:srgbClr val="FF9755"/>
-            </a:solidFill>
-            <a:prstDash val="solid"/>
-          </a:ln>
+            <a:off x="685800" y="1828800"/>
+            <a:ext cx="6949440" cy="4150360"/>
+          </a:xfrm>
+          <a:prstGeom prst="roundRect">
+            <a:avLst>
+              <a:gd name="adj" fmla="val 3084"/>
+            </a:avLst>
+          </a:prstGeom>
+          <a:solidFill>
+            <a:srgbClr val="FFFEFA"/>
+          </a:solidFill>
+          <a:ln w="9525">
+            <a:solidFill>
+              <a:srgbClr val="D6D4CC"/>
+            </a:solidFill>
+            <a:prstDash val="solid"/>
+          </a:ln>
+          <a:effectLst>
+            <a:outerShdw sx="100000" sy="100000" kx="0" ky="0" algn="bl" rotWithShape="0" blurRad="127000" dist="38100" dir="5400000">
+              <a:srgbClr val="3C3828">
+                <a:alpha val="12000"/>
+              </a:srgbClr>
+            </a:outerShdw>
+          </a:effectLst>
         </p:spPr>
       </p:sp>
       <p:pic>
         <p:nvPicPr>
-          <p:cNvPr id="5" name="Image 0" descr="pencil icon">    </p:cNvPr>
+          <p:cNvPr id="5" name="Image 0" descr="The YAWP! editor on the Body Paragraphs step.">    </p:cNvPr>
           <p:cNvPicPr>
             <a:picLocks noChangeAspect="1"/>
           </p:cNvPicPr>
@@ -12605,8 +13089,8 @@
         </p:blipFill>
         <p:spPr>
           <a:xfrm>
-            <a:off x="10810951" y="630936"/>
-            <a:ext cx="521208" cy="521208"/>
+            <a:off x="813816" y="1956816"/>
+            <a:ext cx="6693408" cy="3894328"/>
           </a:xfrm>
           <a:prstGeom prst="rect">
             <a:avLst/>
@@ -12621,42 +13105,17 @@
         </p:nvSpPr>
         <p:spPr>
           <a:xfrm>
-            <a:off x="10344607" y="530352"/>
-            <a:ext cx="182880" cy="182880"/>
+            <a:off x="8183880" y="2505456"/>
+            <a:ext cx="292608" cy="292608"/>
           </a:xfrm>
           <a:prstGeom prst="ellipse">
             <a:avLst/>
           </a:prstGeom>
           <a:solidFill>
-            <a:srgbClr val="02BDC7"/>
+            <a:srgbClr val="FFB600"/>
           </a:solidFill>
           <a:ln w="12700">
             <a:solidFill>
-              <a:srgbClr val="02BDC7"/>
-            </a:solidFill>
-            <a:prstDash val="solid"/>
-          </a:ln>
-        </p:spPr>
-      </p:sp>
-      <p:sp>
-        <p:nvSpPr>
-          <p:cNvPr id="7" name="Shape 4"/>
-          <p:cNvSpPr/>
-          <p:nvPr/>
-        </p:nvSpPr>
-        <p:spPr>
-          <a:xfrm>
-            <a:off x="11460175" y="1307592"/>
-            <a:ext cx="128016" cy="128016"/>
-          </a:xfrm>
-          <a:prstGeom prst="ellipse">
-            <a:avLst/>
-          </a:prstGeom>
-          <a:solidFill>
-            <a:srgbClr val="FFB600"/>
-          </a:solidFill>
-          <a:ln w="12700">
-            <a:solidFill>
               <a:srgbClr val="FFB600"/>
             </a:solidFill>
             <a:prstDash val="solid"/>
@@ -12665,98 +13124,14 @@
       </p:sp>
       <p:sp>
         <p:nvSpPr>
-          <p:cNvPr id="8" name="Shape 5"/>
-          <p:cNvSpPr/>
-          <p:nvPr/>
-        </p:nvSpPr>
-        <p:spPr>
-          <a:xfrm>
-            <a:off x="685800" y="1965960"/>
-            <a:ext cx="5250028" cy="1897380"/>
-          </a:xfrm>
-          <a:prstGeom prst="roundRect">
-            <a:avLst>
-              <a:gd name="adj" fmla="val 6747"/>
-            </a:avLst>
-          </a:prstGeom>
-          <a:solidFill>
-            <a:srgbClr val="FFFEFA"/>
-          </a:solidFill>
-          <a:ln w="9525">
-            <a:solidFill>
-              <a:srgbClr val="D6D4CC"/>
-            </a:solidFill>
-            <a:prstDash val="solid"/>
-          </a:ln>
-          <a:effectLst>
-            <a:outerShdw sx="100000" sy="100000" kx="0" ky="0" algn="bl" rotWithShape="0" blurRad="127000" dist="38100" dir="5400000">
-              <a:srgbClr val="3C3828">
-                <a:alpha val="12000"/>
-              </a:srgbClr>
-            </a:outerShdw>
-          </a:effectLst>
-        </p:spPr>
-      </p:sp>
-      <p:sp>
-        <p:nvSpPr>
-          <p:cNvPr id="9" name="Shape 6"/>
-          <p:cNvSpPr/>
-          <p:nvPr/>
-        </p:nvSpPr>
-        <p:spPr>
-          <a:xfrm>
-            <a:off x="813816" y="1965960"/>
-            <a:ext cx="4993996" cy="91440"/>
-          </a:xfrm>
-          <a:prstGeom prst="rect">
-            <a:avLst/>
-          </a:prstGeom>
-          <a:solidFill>
-            <a:srgbClr val="FF9755"/>
-          </a:solidFill>
-          <a:ln w="12700">
-            <a:solidFill>
-              <a:srgbClr val="FF9755"/>
-            </a:solidFill>
-            <a:prstDash val="solid"/>
-          </a:ln>
-        </p:spPr>
-      </p:sp>
-      <p:sp>
-        <p:nvSpPr>
-          <p:cNvPr id="10" name="Shape 7"/>
-          <p:cNvSpPr/>
-          <p:nvPr/>
-        </p:nvSpPr>
-        <p:spPr>
-          <a:xfrm>
-            <a:off x="960120" y="2286000"/>
-            <a:ext cx="548640" cy="548640"/>
-          </a:xfrm>
-          <a:prstGeom prst="ellipse">
-            <a:avLst/>
-          </a:prstGeom>
-          <a:solidFill>
-            <a:srgbClr val="FF9755"/>
-          </a:solidFill>
-          <a:ln w="12700">
-            <a:solidFill>
-              <a:srgbClr val="FF9755"/>
-            </a:solidFill>
-            <a:prstDash val="solid"/>
-          </a:ln>
-        </p:spPr>
-      </p:sp>
-      <p:sp>
-        <p:nvSpPr>
-          <p:cNvPr id="11" name="Text 8"/>
-          <p:cNvSpPr/>
-          <p:nvPr/>
-        </p:nvSpPr>
-        <p:spPr>
-          <a:xfrm>
-            <a:off x="960120" y="2286000"/>
-            <a:ext cx="548640" cy="548640"/>
+          <p:cNvPr id="7" name="Text 4"/>
+          <p:cNvSpPr/>
+          <p:nvPr/>
+        </p:nvSpPr>
+        <p:spPr>
+          <a:xfrm>
+            <a:off x="8659368" y="2194560"/>
+            <a:ext cx="2846527" cy="914400"/>
           </a:xfrm>
           <a:prstGeom prst="rect">
             <a:avLst/>
@@ -12768,48 +13143,20 @@
           <a:bodyPr wrap="square" lIns="0" tIns="0" rIns="0" bIns="0" rtlCol="0" anchor="ctr"/>
           <a:lstStyle/>
           <a:p>
-            <a:pPr algn="ctr" indent="0" marL="0">
-              <a:buNone/>
-            </a:pPr>
-            <a:r>
-              <a:rPr lang="en-US" sz="2200" b="1" dirty="0">
-                <a:solidFill>
-                  <a:srgbClr val="FFFEFA"/>
-                </a:solidFill>
-                <a:latin typeface="Georgia" pitchFamily="34" charset="0"/>
-                <a:ea typeface="Georgia" pitchFamily="34" charset="-122"/>
-                <a:cs typeface="Georgia" pitchFamily="34" charset="-120"/>
-              </a:rPr>
-              <a:t>1</a:t>
-            </a:r>
-            <a:endParaRPr lang="en-US" sz="2200" dirty="0"/>
-          </a:p>
-        </p:txBody>
-      </p:sp>
-      <p:sp>
-        <p:nvSpPr>
-          <p:cNvPr id="12" name="Text 9"/>
-          <p:cNvSpPr/>
-          <p:nvPr/>
-        </p:nvSpPr>
-        <p:spPr>
-          <a:xfrm>
-            <a:off x="1737360" y="2194560"/>
-            <a:ext cx="3924148" cy="1485900"/>
-          </a:xfrm>
-          <a:prstGeom prst="rect">
-            <a:avLst/>
-          </a:prstGeom>
-          <a:noFill/>
-          <a:ln/>
-        </p:spPr>
-        <p:txBody>
-          <a:bodyPr wrap="square" lIns="0" tIns="0" rIns="0" bIns="0" rtlCol="0" anchor="t"/>
-          <a:lstStyle/>
-          <a:p>
             <a:pPr indent="0" marL="0">
               <a:buNone/>
             </a:pPr>
+            <a:r>
+              <a:rPr lang="en-US" sz="2000" dirty="0">
+                <a:solidFill>
+                  <a:srgbClr val="3C3828"/>
+                </a:solidFill>
+                <a:latin typeface="Calibri" pitchFamily="34" charset="0"/>
+                <a:ea typeface="Calibri" pitchFamily="34" charset="-122"/>
+                <a:cs typeface="Calibri" pitchFamily="34" charset="-120"/>
+              </a:rPr>
+              <a:t>The Tutor says </a:t>
+            </a:r>
             <a:r>
               <a:rPr lang="en-US" sz="2000" dirty="0">
                 <a:solidFill>
@@ -12822,8 +13169,61 @@
                 <a:ea typeface="Calibri" pitchFamily="34" charset="-122"/>
                 <a:cs typeface="Calibri" pitchFamily="34" charset="-120"/>
               </a:rPr>
-              <a:t>The neighborhood</a:t>
-            </a:r>
+              <a:t>Body Paragraphs</a:t>
+            </a:r>
+            <a:endParaRPr lang="en-US" sz="2000" dirty="0"/>
+          </a:p>
+        </p:txBody>
+      </p:sp>
+      <p:sp>
+        <p:nvSpPr>
+          <p:cNvPr id="8" name="Shape 5"/>
+          <p:cNvSpPr/>
+          <p:nvPr/>
+        </p:nvSpPr>
+        <p:spPr>
+          <a:xfrm>
+            <a:off x="8183880" y="3419856"/>
+            <a:ext cx="292608" cy="292608"/>
+          </a:xfrm>
+          <a:prstGeom prst="ellipse">
+            <a:avLst/>
+          </a:prstGeom>
+          <a:solidFill>
+            <a:srgbClr val="FC4540"/>
+          </a:solidFill>
+          <a:ln w="12700">
+            <a:solidFill>
+              <a:srgbClr val="FC4540"/>
+            </a:solidFill>
+            <a:prstDash val="solid"/>
+          </a:ln>
+        </p:spPr>
+      </p:sp>
+      <p:sp>
+        <p:nvSpPr>
+          <p:cNvPr id="9" name="Text 6"/>
+          <p:cNvSpPr/>
+          <p:nvPr/>
+        </p:nvSpPr>
+        <p:spPr>
+          <a:xfrm>
+            <a:off x="8659368" y="3108960"/>
+            <a:ext cx="2846527" cy="914400"/>
+          </a:xfrm>
+          <a:prstGeom prst="rect">
+            <a:avLst/>
+          </a:prstGeom>
+          <a:noFill/>
+          <a:ln/>
+        </p:spPr>
+        <p:txBody>
+          <a:bodyPr wrap="square" lIns="0" tIns="0" rIns="0" bIns="0" rtlCol="0" anchor="ctr"/>
+          <a:lstStyle/>
+          <a:p>
+            <a:pPr indent="0" marL="0">
+              <a:buNone/>
+            </a:pPr>
             <a:r>
               <a:rPr lang="en-US" sz="2000" dirty="0">
                 <a:solidFill>
@@ -12833,7 +13233,7 @@
                 <a:ea typeface="Calibri" pitchFamily="34" charset="-122"/>
                 <a:cs typeface="Calibri" pitchFamily="34" charset="-120"/>
               </a:rPr>
-              <a:t> · Driving in, your reader gets a sense of where they are. That’s your introduction: context.</a:t>
+              <a:t>Your thesis, in its parts</a:t>
             </a:r>
             <a:endParaRPr lang="en-US" sz="2000" dirty="0"/>
           </a:p>
@@ -12841,98 +13241,39 @@
       </p:sp>
       <p:sp>
         <p:nvSpPr>
-          <p:cNvPr id="13" name="Shape 10"/>
-          <p:cNvSpPr/>
-          <p:nvPr/>
-        </p:nvSpPr>
-        <p:spPr>
-          <a:xfrm>
-            <a:off x="6255868" y="1965960"/>
-            <a:ext cx="5250028" cy="1897380"/>
-          </a:xfrm>
-          <a:prstGeom prst="roundRect">
-            <a:avLst>
-              <a:gd name="adj" fmla="val 6747"/>
-            </a:avLst>
-          </a:prstGeom>
-          <a:solidFill>
-            <a:srgbClr val="FFFEFA"/>
-          </a:solidFill>
-          <a:ln w="9525">
-            <a:solidFill>
-              <a:srgbClr val="D6D4CC"/>
-            </a:solidFill>
-            <a:prstDash val="solid"/>
-          </a:ln>
-          <a:effectLst>
-            <a:outerShdw sx="100000" sy="100000" kx="0" ky="0" algn="bl" rotWithShape="0" blurRad="127000" dist="38100" dir="5400000">
-              <a:srgbClr val="3C3828">
-                <a:alpha val="12000"/>
-              </a:srgbClr>
-            </a:outerShdw>
-          </a:effectLst>
-        </p:spPr>
-      </p:sp>
-      <p:sp>
-        <p:nvSpPr>
-          <p:cNvPr id="14" name="Shape 11"/>
-          <p:cNvSpPr/>
-          <p:nvPr/>
-        </p:nvSpPr>
-        <p:spPr>
-          <a:xfrm>
-            <a:off x="6383884" y="1965960"/>
-            <a:ext cx="4993996" cy="91440"/>
-          </a:xfrm>
-          <a:prstGeom prst="rect">
-            <a:avLst/>
-          </a:prstGeom>
-          <a:solidFill>
-            <a:srgbClr val="FC4067"/>
+          <p:cNvPr id="10" name="Shape 7"/>
+          <p:cNvSpPr/>
+          <p:nvPr/>
+        </p:nvSpPr>
+        <p:spPr>
+          <a:xfrm>
+            <a:off x="8183880" y="4334256"/>
+            <a:ext cx="292608" cy="292608"/>
+          </a:xfrm>
+          <a:prstGeom prst="ellipse">
+            <a:avLst/>
+          </a:prstGeom>
+          <a:solidFill>
+            <a:srgbClr val="FF9755"/>
           </a:solidFill>
           <a:ln w="12700">
             <a:solidFill>
-              <a:srgbClr val="FC4067"/>
-            </a:solidFill>
-            <a:prstDash val="solid"/>
-          </a:ln>
-        </p:spPr>
-      </p:sp>
-      <p:sp>
-        <p:nvSpPr>
-          <p:cNvPr id="15" name="Shape 12"/>
-          <p:cNvSpPr/>
-          <p:nvPr/>
-        </p:nvSpPr>
-        <p:spPr>
-          <a:xfrm>
-            <a:off x="6530188" y="2286000"/>
-            <a:ext cx="548640" cy="548640"/>
-          </a:xfrm>
-          <a:prstGeom prst="ellipse">
-            <a:avLst/>
-          </a:prstGeom>
-          <a:solidFill>
-            <a:srgbClr val="FC4067"/>
-          </a:solidFill>
-          <a:ln w="12700">
-            <a:solidFill>
-              <a:srgbClr val="FC4067"/>
-            </a:solidFill>
-            <a:prstDash val="solid"/>
-          </a:ln>
-        </p:spPr>
-      </p:sp>
-      <p:sp>
-        <p:nvSpPr>
-          <p:cNvPr id="16" name="Text 13"/>
-          <p:cNvSpPr/>
-          <p:nvPr/>
-        </p:nvSpPr>
-        <p:spPr>
-          <a:xfrm>
-            <a:off x="6530188" y="2286000"/>
-            <a:ext cx="548640" cy="548640"/>
+              <a:srgbClr val="FF9755"/>
+            </a:solidFill>
+            <a:prstDash val="solid"/>
+          </a:ln>
+        </p:spPr>
+      </p:sp>
+      <p:sp>
+        <p:nvSpPr>
+          <p:cNvPr id="11" name="Text 8"/>
+          <p:cNvSpPr/>
+          <p:nvPr/>
+        </p:nvSpPr>
+        <p:spPr>
+          <a:xfrm>
+            <a:off x="8659368" y="4023360"/>
+            <a:ext cx="2846527" cy="914400"/>
           </a:xfrm>
           <a:prstGeom prst="rect">
             <a:avLst/>
@@ -12944,45 +13285,6 @@
           <a:bodyPr wrap="square" lIns="0" tIns="0" rIns="0" bIns="0" rtlCol="0" anchor="ctr"/>
           <a:lstStyle/>
           <a:p>
-            <a:pPr algn="ctr" indent="0" marL="0">
-              <a:buNone/>
-            </a:pPr>
-            <a:r>
-              <a:rPr lang="en-US" sz="2200" b="1" dirty="0">
-                <a:solidFill>
-                  <a:srgbClr val="FFFEFA"/>
-                </a:solidFill>
-                <a:latin typeface="Georgia" pitchFamily="34" charset="0"/>
-                <a:ea typeface="Georgia" pitchFamily="34" charset="-122"/>
-                <a:cs typeface="Georgia" pitchFamily="34" charset="-120"/>
-              </a:rPr>
-              <a:t>2</a:t>
-            </a:r>
-            <a:endParaRPr lang="en-US" sz="2200" dirty="0"/>
-          </a:p>
-        </p:txBody>
-      </p:sp>
-      <p:sp>
-        <p:nvSpPr>
-          <p:cNvPr id="17" name="Text 14"/>
-          <p:cNvSpPr/>
-          <p:nvPr/>
-        </p:nvSpPr>
-        <p:spPr>
-          <a:xfrm>
-            <a:off x="7307428" y="2194560"/>
-            <a:ext cx="3924148" cy="1485900"/>
-          </a:xfrm>
-          <a:prstGeom prst="rect">
-            <a:avLst/>
-          </a:prstGeom>
-          <a:noFill/>
-          <a:ln/>
-        </p:spPr>
-        <p:txBody>
-          <a:bodyPr wrap="square" lIns="0" tIns="0" rIns="0" bIns="0" rtlCol="0" anchor="t"/>
-          <a:lstStyle/>
-          <a:p>
             <a:pPr indent="0" marL="0">
               <a:buNone/>
             </a:pPr>
@@ -12991,15 +13293,65 @@
                 <a:solidFill>
                   <a:srgbClr val="3C3828"/>
                 </a:solidFill>
-                <a:highlight>
-                  <a:srgbClr val="FFE14D"/>
-                </a:highlight>
                 <a:latin typeface="Calibri" pitchFamily="34" charset="0"/>
                 <a:ea typeface="Calibri" pitchFamily="34" charset="-122"/>
                 <a:cs typeface="Calibri" pitchFamily="34" charset="-120"/>
               </a:rPr>
-              <a:t>The front door</a:t>
-            </a:r>
+              <a:t>One paragraph per part</a:t>
+            </a:r>
+            <a:endParaRPr lang="en-US" sz="2000" dirty="0"/>
+          </a:p>
+        </p:txBody>
+      </p:sp>
+      <p:sp>
+        <p:nvSpPr>
+          <p:cNvPr id="12" name="Shape 9"/>
+          <p:cNvSpPr/>
+          <p:nvPr/>
+        </p:nvSpPr>
+        <p:spPr>
+          <a:xfrm>
+            <a:off x="8183880" y="5248656"/>
+            <a:ext cx="292608" cy="292608"/>
+          </a:xfrm>
+          <a:prstGeom prst="ellipse">
+            <a:avLst/>
+          </a:prstGeom>
+          <a:solidFill>
+            <a:srgbClr val="FC4067"/>
+          </a:solidFill>
+          <a:ln w="12700">
+            <a:solidFill>
+              <a:srgbClr val="FC4067"/>
+            </a:solidFill>
+            <a:prstDash val="solid"/>
+          </a:ln>
+        </p:spPr>
+      </p:sp>
+      <p:sp>
+        <p:nvSpPr>
+          <p:cNvPr id="13" name="Text 10"/>
+          <p:cNvSpPr/>
+          <p:nvPr/>
+        </p:nvSpPr>
+        <p:spPr>
+          <a:xfrm>
+            <a:off x="8659368" y="4937760"/>
+            <a:ext cx="2846527" cy="914400"/>
+          </a:xfrm>
+          <a:prstGeom prst="rect">
+            <a:avLst/>
+          </a:prstGeom>
+          <a:noFill/>
+          <a:ln/>
+        </p:spPr>
+        <p:txBody>
+          <a:bodyPr wrap="square" lIns="0" tIns="0" rIns="0" bIns="0" rtlCol="0" anchor="ctr"/>
+          <a:lstStyle/>
+          <a:p>
+            <a:pPr indent="0" marL="0">
+              <a:buNone/>
+            </a:pPr>
             <a:r>
               <a:rPr lang="en-US" sz="2000" dirty="0">
                 <a:solidFill>
@@ -13009,359 +13361,7 @@
                 <a:ea typeface="Calibri" pitchFamily="34" charset="-122"/>
                 <a:cs typeface="Calibri" pitchFamily="34" charset="-120"/>
               </a:rPr>
-              <a:t> · They step into the foyer and see the whole house at once. That’s your thesis statement.</a:t>
-            </a:r>
-            <a:endParaRPr lang="en-US" sz="2000" dirty="0"/>
-          </a:p>
-        </p:txBody>
-      </p:sp>
-      <p:sp>
-        <p:nvSpPr>
-          <p:cNvPr id="18" name="Shape 15"/>
-          <p:cNvSpPr/>
-          <p:nvPr/>
-        </p:nvSpPr>
-        <p:spPr>
-          <a:xfrm>
-            <a:off x="685800" y="4183380"/>
-            <a:ext cx="5250028" cy="1897380"/>
-          </a:xfrm>
-          <a:prstGeom prst="roundRect">
-            <a:avLst>
-              <a:gd name="adj" fmla="val 6747"/>
-            </a:avLst>
-          </a:prstGeom>
-          <a:solidFill>
-            <a:srgbClr val="FFFEFA"/>
-          </a:solidFill>
-          <a:ln w="9525">
-            <a:solidFill>
-              <a:srgbClr val="D6D4CC"/>
-            </a:solidFill>
-            <a:prstDash val="solid"/>
-          </a:ln>
-          <a:effectLst>
-            <a:outerShdw sx="100000" sy="100000" kx="0" ky="0" algn="bl" rotWithShape="0" blurRad="127000" dist="38100" dir="5400000">
-              <a:srgbClr val="3C3828">
-                <a:alpha val="12000"/>
-              </a:srgbClr>
-            </a:outerShdw>
-          </a:effectLst>
-        </p:spPr>
-      </p:sp>
-      <p:sp>
-        <p:nvSpPr>
-          <p:cNvPr id="19" name="Shape 16"/>
-          <p:cNvSpPr/>
-          <p:nvPr/>
-        </p:nvSpPr>
-        <p:spPr>
-          <a:xfrm>
-            <a:off x="813816" y="4183380"/>
-            <a:ext cx="4993996" cy="91440"/>
-          </a:xfrm>
-          <a:prstGeom prst="rect">
-            <a:avLst/>
-          </a:prstGeom>
-          <a:solidFill>
-            <a:srgbClr val="02BDC7"/>
-          </a:solidFill>
-          <a:ln w="12700">
-            <a:solidFill>
-              <a:srgbClr val="02BDC7"/>
-            </a:solidFill>
-            <a:prstDash val="solid"/>
-          </a:ln>
-        </p:spPr>
-      </p:sp>
-      <p:sp>
-        <p:nvSpPr>
-          <p:cNvPr id="20" name="Shape 17"/>
-          <p:cNvSpPr/>
-          <p:nvPr/>
-        </p:nvSpPr>
-        <p:spPr>
-          <a:xfrm>
-            <a:off x="960120" y="4503420"/>
-            <a:ext cx="548640" cy="548640"/>
-          </a:xfrm>
-          <a:prstGeom prst="ellipse">
-            <a:avLst/>
-          </a:prstGeom>
-          <a:solidFill>
-            <a:srgbClr val="02BDC7"/>
-          </a:solidFill>
-          <a:ln w="12700">
-            <a:solidFill>
-              <a:srgbClr val="02BDC7"/>
-            </a:solidFill>
-            <a:prstDash val="solid"/>
-          </a:ln>
-        </p:spPr>
-      </p:sp>
-      <p:sp>
-        <p:nvSpPr>
-          <p:cNvPr id="21" name="Text 18"/>
-          <p:cNvSpPr/>
-          <p:nvPr/>
-        </p:nvSpPr>
-        <p:spPr>
-          <a:xfrm>
-            <a:off x="960120" y="4503420"/>
-            <a:ext cx="548640" cy="548640"/>
-          </a:xfrm>
-          <a:prstGeom prst="rect">
-            <a:avLst/>
-          </a:prstGeom>
-          <a:noFill/>
-          <a:ln/>
-        </p:spPr>
-        <p:txBody>
-          <a:bodyPr wrap="square" lIns="0" tIns="0" rIns="0" bIns="0" rtlCol="0" anchor="ctr"/>
-          <a:lstStyle/>
-          <a:p>
-            <a:pPr algn="ctr" indent="0" marL="0">
-              <a:buNone/>
-            </a:pPr>
-            <a:r>
-              <a:rPr lang="en-US" sz="2200" b="1" dirty="0">
-                <a:solidFill>
-                  <a:srgbClr val="FFFEFA"/>
-                </a:solidFill>
-                <a:latin typeface="Georgia" pitchFamily="34" charset="0"/>
-                <a:ea typeface="Georgia" pitchFamily="34" charset="-122"/>
-                <a:cs typeface="Georgia" pitchFamily="34" charset="-120"/>
-              </a:rPr>
-              <a:t>3</a:t>
-            </a:r>
-            <a:endParaRPr lang="en-US" sz="2200" dirty="0"/>
-          </a:p>
-        </p:txBody>
-      </p:sp>
-      <p:sp>
-        <p:nvSpPr>
-          <p:cNvPr id="22" name="Text 19"/>
-          <p:cNvSpPr/>
-          <p:nvPr/>
-        </p:nvSpPr>
-        <p:spPr>
-          <a:xfrm>
-            <a:off x="1737360" y="4411980"/>
-            <a:ext cx="3924148" cy="1485900"/>
-          </a:xfrm>
-          <a:prstGeom prst="rect">
-            <a:avLst/>
-          </a:prstGeom>
-          <a:noFill/>
-          <a:ln/>
-        </p:spPr>
-        <p:txBody>
-          <a:bodyPr wrap="square" lIns="0" tIns="0" rIns="0" bIns="0" rtlCol="0" anchor="t"/>
-          <a:lstStyle/>
-          <a:p>
-            <a:pPr indent="0" marL="0">
-              <a:buNone/>
-            </a:pPr>
-            <a:r>
-              <a:rPr lang="en-US" sz="2000" dirty="0">
-                <a:solidFill>
-                  <a:srgbClr val="3C3828"/>
-                </a:solidFill>
-                <a:highlight>
-                  <a:srgbClr val="FFE14D"/>
-                </a:highlight>
-                <a:latin typeface="Calibri" pitchFamily="34" charset="0"/>
-                <a:ea typeface="Calibri" pitchFamily="34" charset="-122"/>
-                <a:cs typeface="Calibri" pitchFamily="34" charset="-120"/>
-              </a:rPr>
-              <a:t>The rooms</a:t>
-            </a:r>
-            <a:r>
-              <a:rPr lang="en-US" sz="2000" dirty="0">
-                <a:solidFill>
-                  <a:srgbClr val="3C3828"/>
-                </a:solidFill>
-                <a:latin typeface="Calibri" pitchFamily="34" charset="0"/>
-                <a:ea typeface="Calibri" pitchFamily="34" charset="-122"/>
-                <a:cs typeface="Calibri" pitchFamily="34" charset="-120"/>
-              </a:rPr>
-              <a:t> · You walk them through, pointing out what makes each room worth it. Those are your body paragraphs.</a:t>
-            </a:r>
-            <a:endParaRPr lang="en-US" sz="2000" dirty="0"/>
-          </a:p>
-        </p:txBody>
-      </p:sp>
-      <p:sp>
-        <p:nvSpPr>
-          <p:cNvPr id="23" name="Shape 20"/>
-          <p:cNvSpPr/>
-          <p:nvPr/>
-        </p:nvSpPr>
-        <p:spPr>
-          <a:xfrm>
-            <a:off x="6255868" y="4183380"/>
-            <a:ext cx="5250028" cy="1897380"/>
-          </a:xfrm>
-          <a:prstGeom prst="roundRect">
-            <a:avLst>
-              <a:gd name="adj" fmla="val 6747"/>
-            </a:avLst>
-          </a:prstGeom>
-          <a:solidFill>
-            <a:srgbClr val="FFFEFA"/>
-          </a:solidFill>
-          <a:ln w="9525">
-            <a:solidFill>
-              <a:srgbClr val="D6D4CC"/>
-            </a:solidFill>
-            <a:prstDash val="solid"/>
-          </a:ln>
-          <a:effectLst>
-            <a:outerShdw sx="100000" sy="100000" kx="0" ky="0" algn="bl" rotWithShape="0" blurRad="127000" dist="38100" dir="5400000">
-              <a:srgbClr val="3C3828">
-                <a:alpha val="12000"/>
-              </a:srgbClr>
-            </a:outerShdw>
-          </a:effectLst>
-        </p:spPr>
-      </p:sp>
-      <p:sp>
-        <p:nvSpPr>
-          <p:cNvPr id="24" name="Shape 21"/>
-          <p:cNvSpPr/>
-          <p:nvPr/>
-        </p:nvSpPr>
-        <p:spPr>
-          <a:xfrm>
-            <a:off x="6383884" y="4183380"/>
-            <a:ext cx="4993996" cy="91440"/>
-          </a:xfrm>
-          <a:prstGeom prst="rect">
-            <a:avLst/>
-          </a:prstGeom>
-          <a:solidFill>
-            <a:srgbClr val="FFB600"/>
-          </a:solidFill>
-          <a:ln w="12700">
-            <a:solidFill>
-              <a:srgbClr val="FFB600"/>
-            </a:solidFill>
-            <a:prstDash val="solid"/>
-          </a:ln>
-        </p:spPr>
-      </p:sp>
-      <p:sp>
-        <p:nvSpPr>
-          <p:cNvPr id="25" name="Shape 22"/>
-          <p:cNvSpPr/>
-          <p:nvPr/>
-        </p:nvSpPr>
-        <p:spPr>
-          <a:xfrm>
-            <a:off x="6530188" y="4503420"/>
-            <a:ext cx="548640" cy="548640"/>
-          </a:xfrm>
-          <a:prstGeom prst="ellipse">
-            <a:avLst/>
-          </a:prstGeom>
-          <a:solidFill>
-            <a:srgbClr val="FFB600"/>
-          </a:solidFill>
-          <a:ln w="12700">
-            <a:solidFill>
-              <a:srgbClr val="FFB600"/>
-            </a:solidFill>
-            <a:prstDash val="solid"/>
-          </a:ln>
-        </p:spPr>
-      </p:sp>
-      <p:sp>
-        <p:nvSpPr>
-          <p:cNvPr id="26" name="Text 23"/>
-          <p:cNvSpPr/>
-          <p:nvPr/>
-        </p:nvSpPr>
-        <p:spPr>
-          <a:xfrm>
-            <a:off x="6530188" y="4503420"/>
-            <a:ext cx="548640" cy="548640"/>
-          </a:xfrm>
-          <a:prstGeom prst="rect">
-            <a:avLst/>
-          </a:prstGeom>
-          <a:noFill/>
-          <a:ln/>
-        </p:spPr>
-        <p:txBody>
-          <a:bodyPr wrap="square" lIns="0" tIns="0" rIns="0" bIns="0" rtlCol="0" anchor="ctr"/>
-          <a:lstStyle/>
-          <a:p>
-            <a:pPr algn="ctr" indent="0" marL="0">
-              <a:buNone/>
-            </a:pPr>
-            <a:r>
-              <a:rPr lang="en-US" sz="2200" b="1" dirty="0">
-                <a:solidFill>
-                  <a:srgbClr val="FFFEFA"/>
-                </a:solidFill>
-                <a:latin typeface="Georgia" pitchFamily="34" charset="0"/>
-                <a:ea typeface="Georgia" pitchFamily="34" charset="-122"/>
-                <a:cs typeface="Georgia" pitchFamily="34" charset="-120"/>
-              </a:rPr>
-              <a:t>4</a:t>
-            </a:r>
-            <a:endParaRPr lang="en-US" sz="2200" dirty="0"/>
-          </a:p>
-        </p:txBody>
-      </p:sp>
-      <p:sp>
-        <p:nvSpPr>
-          <p:cNvPr id="27" name="Text 24"/>
-          <p:cNvSpPr/>
-          <p:nvPr/>
-        </p:nvSpPr>
-        <p:spPr>
-          <a:xfrm>
-            <a:off x="7307428" y="4411980"/>
-            <a:ext cx="3924148" cy="1485900"/>
-          </a:xfrm>
-          <a:prstGeom prst="rect">
-            <a:avLst/>
-          </a:prstGeom>
-          <a:noFill/>
-          <a:ln/>
-        </p:spPr>
-        <p:txBody>
-          <a:bodyPr wrap="square" lIns="0" tIns="0" rIns="0" bIns="0" rtlCol="0" anchor="t"/>
-          <a:lstStyle/>
-          <a:p>
-            <a:pPr indent="0" marL="0">
-              <a:buNone/>
-            </a:pPr>
-            <a:r>
-              <a:rPr lang="en-US" sz="2000" dirty="0">
-                <a:solidFill>
-                  <a:srgbClr val="3C3828"/>
-                </a:solidFill>
-                <a:highlight>
-                  <a:srgbClr val="FFE14D"/>
-                </a:highlight>
-                <a:latin typeface="Calibri" pitchFamily="34" charset="0"/>
-                <a:ea typeface="Calibri" pitchFamily="34" charset="-122"/>
-                <a:cs typeface="Calibri" pitchFamily="34" charset="-120"/>
-              </a:rPr>
-              <a:t>Back at the door</a:t>
-            </a:r>
-            <a:r>
-              <a:rPr lang="en-US" sz="2000" dirty="0">
-                <a:solidFill>
-                  <a:srgbClr val="3C3828"/>
-                </a:solidFill>
-                <a:latin typeface="Calibri" pitchFamily="34" charset="0"/>
-                <a:ea typeface="Calibri" pitchFamily="34" charset="-122"/>
-                <a:cs typeface="Calibri" pitchFamily="34" charset="-120"/>
-              </a:rPr>
-              <a:t> · You step out, point at the neighborhood, and leave gracefully. That’s your conclusion.</a:t>
+              <a:t>Written one? Ask the Tutor for feedback</a:t>
             </a:r>
             <a:endParaRPr lang="en-US" sz="2000" dirty="0"/>
           </a:p>

</xml_diff>